<commit_message>
No-port ablation: retrain without dst port and protocol (macro-F1 0.865 -> 0.868); shown on Method page, METHOD.md and deck
</commit_message>
<xml_diff>
--- a/deck/NIGHTWATCH-DataNova2026.pptx
+++ b/deck/NIGHTWATCH-DataNova2026.pptx
@@ -120,25 +120,25 @@
   <p:extLst>
     <p:ext uri="{521415D9-36F7-43E2-AB2F-B90AF26B5E84}">
       <p14:sectionLst xmlns:p14="http://schemas.microsoft.com/office/powerpoint/2010/main">
-        <p14:section name="Opening" id="{9a9db45e-8d07-e6c2-8407-94408da76f3f}">
+        <p14:section name="Opening" id="{4d60c91c-aee4-81f3-7f06-d311ab741684}">
           <p14:sldIdLst>
             <p14:sldId id="256"/>
           </p14:sldIdLst>
         </p14:section>
-        <p14:section name="Problem" id="{19485d23-a60c-de13-2c32-72791d64b8a8}">
+        <p14:section name="Problem" id="{6b38cab6-78f3-2ac4-d0ca-35b9009bd714}">
           <p14:sldIdLst>
             <p14:sldId id="257"/>
             <p14:sldId id="258"/>
           </p14:sldIdLst>
         </p14:section>
-        <p14:section name="Solution" id="{8caf3d4a-2bd6-3344-9331-ec4d0387d22d}">
+        <p14:section name="Solution" id="{7e72a43e-52e8-3632-ff00-32db246302ec}">
           <p14:sldIdLst>
             <p14:sldId id="259"/>
             <p14:sldId id="260"/>
             <p14:sldId id="261"/>
           </p14:sldIdLst>
         </p14:section>
-        <p14:section name="Evidence" id="{95bc9772-9aa2-25d2-e4c5-6bf7185ce413}">
+        <p14:section name="Evidence" id="{df6078f1-a705-18d8-dd0e-f828b0abed7c}">
           <p14:sldIdLst>
             <p14:sldId id="262"/>
             <p14:sldId id="263"/>
@@ -146,14 +146,14 @@
             <p14:sldId id="265"/>
           </p14:sldIdLst>
         </p14:section>
-        <p14:section name="Impact" id="{a6a2a48b-c1b5-e72c-2552-43ef8d94f15d}">
+        <p14:section name="Impact" id="{d1dd6630-6b7a-f243-0250-5c1b2a45d3d6}">
           <p14:sldIdLst>
             <p14:sldId id="266"/>
             <p14:sldId id="267"/>
             <p14:sldId id="268"/>
           </p14:sldIdLst>
         </p14:section>
-        <p14:section name="Close" id="{c99cf343-0637-4389-1156-3e64ae3e8ea1}">
+        <p14:section name="Close" id="{ae95430d-e911-b159-6ff2-15b4eb344403}">
           <p14:sldIdLst>
             <p14:sldId id="269"/>
           </p14:sldIdLst>
@@ -9384,7 +9384,7 @@
         </p:nvSpPr>
         <p:spPr>
           <a:xfrm>
-            <a:off x="548640" y="3200400"/>
+            <a:off x="548640" y="3063240"/>
             <a:ext cx="1737360" cy="548640"/>
           </a:xfrm>
           <a:prstGeom prst="rect">
@@ -9420,7 +9420,7 @@
         </p:nvSpPr>
         <p:spPr>
           <a:xfrm>
-            <a:off x="2377440" y="3218688"/>
+            <a:off x="2377440" y="3081528"/>
             <a:ext cx="3291840" cy="1097280"/>
           </a:xfrm>
           <a:prstGeom prst="rect">
@@ -9456,7 +9456,7 @@
         </p:nvSpPr>
         <p:spPr>
           <a:xfrm>
-            <a:off x="548640" y="4526280"/>
+            <a:off x="548640" y="4050792"/>
             <a:ext cx="1737360" cy="548640"/>
           </a:xfrm>
           <a:prstGeom prst="rect">
@@ -9492,7 +9492,7 @@
         </p:nvSpPr>
         <p:spPr>
           <a:xfrm>
-            <a:off x="2377440" y="4544568"/>
+            <a:off x="2377440" y="4069080"/>
             <a:ext cx="3291840" cy="1097280"/>
           </a:xfrm>
           <a:prstGeom prst="rect">
@@ -9520,9 +9520,81 @@
           </a:p>
         </p:txBody>
       </p:sp>
+      <p:sp>
+        <p:nvSpPr>
+          <p:cNvPr id="8" name="Text 6"/>
+          <p:cNvSpPr txBox="1"/>
+          <p:nvPr/>
+        </p:nvSpPr>
+        <p:spPr>
+          <a:xfrm>
+            <a:off x="548640" y="5038344"/>
+            <a:ext cx="1737360" cy="548640"/>
+          </a:xfrm>
+          <a:prstGeom prst="rect">
+            <a:avLst/>
+          </a:prstGeom>
+          <a:noFill/>
+          <a:ln/>
+        </p:spPr>
+        <p:txBody>
+          <a:bodyPr wrap="square" lIns="0" tIns="0" rIns="0" bIns="0" rtlCol="0" anchor="t"/>
+          <a:lstStyle/>
+          <a:p>
+            <a:pPr indent="0" marL="0">
+              <a:buNone/>
+            </a:pPr>
+            <a:r>
+              <a:rPr lang="en-US" sz="2800" b="1" dirty="0">
+                <a:solidFill>
+                  <a:schemeClr val="accent2"/>
+                </a:solidFill>
+              </a:rPr>
+              <a:t>86.8%</a:t>
+            </a:r>
+            <a:endParaRPr lang="en-US" sz="2800" dirty="0"/>
+          </a:p>
+        </p:txBody>
+      </p:sp>
+      <p:sp>
+        <p:nvSpPr>
+          <p:cNvPr id="9" name="Text 7"/>
+          <p:cNvSpPr txBox="1"/>
+          <p:nvPr/>
+        </p:nvSpPr>
+        <p:spPr>
+          <a:xfrm>
+            <a:off x="2377440" y="5056632"/>
+            <a:ext cx="3291840" cy="1097280"/>
+          </a:xfrm>
+          <a:prstGeom prst="rect">
+            <a:avLst/>
+          </a:prstGeom>
+          <a:noFill/>
+          <a:ln/>
+        </p:spPr>
+        <p:txBody>
+          <a:bodyPr wrap="square" lIns="0" tIns="0" rIns="0" bIns="0" rtlCol="0" anchor="t"/>
+          <a:lstStyle/>
+          <a:p>
+            <a:pPr indent="0" marL="0">
+              <a:buNone/>
+            </a:pPr>
+            <a:r>
+              <a:rPr lang="en-US" sz="1400" dirty="0">
+                <a:solidFill>
+                  <a:schemeClr val="bg2"/>
+                </a:solidFill>
+              </a:rPr>
+              <a:t>macro-F1 with port and protocol removed. It reads behavior, not port numbers.</a:t>
+            </a:r>
+            <a:endParaRPr lang="en-US" sz="1400" dirty="0"/>
+          </a:p>
+        </p:txBody>
+      </p:sp>
       <p:graphicFrame>
         <p:nvGraphicFramePr>
-          <p:cNvPr id="8" name="Chart 0" descr=""/>
+          <p:cNvPr id="10" name="Chart 0" descr=""/>
           <p:cNvGraphicFramePr/>
           <p:nvPr/>
         </p:nvGraphicFramePr>
@@ -9538,7 +9610,7 @@
       </p:graphicFrame>
       <p:sp>
         <p:nvSpPr>
-          <p:cNvPr id="9" name="Text 6"/>
+          <p:cNvPr id="11" name="Text 8"/>
           <p:cNvSpPr txBox="1"/>
           <p:nvPr/>
         </p:nvSpPr>
@@ -9566,7 +9638,7 @@
                   <a:srgbClr val="7D8689"/>
                 </a:solidFill>
               </a:rPr>
-              <a:t>Sources: Engelen et al., IEEE SPW 2021; Liu et al., IEEE CNS 2022; Arp et al., USENIX Security 2022. Numbers: ml/reports/illusion.json.</a:t>
+              <a:t>Sources: Engelen et al., IEEE SPW 2021; Liu et al., IEEE CNS 2022; Arp et al., USENIX Security 2022. Numbers: ml/reports/illusion.json, no_port.json.</a:t>
             </a:r>
             <a:endParaRPr lang="en-US" sz="1000" dirty="0"/>
           </a:p>

</xml_diff>

<commit_message>
Deck: production screenshots, live demo and repo URLs on the close
</commit_message>
<xml_diff>
--- a/deck/NIGHTWATCH-DataNova2026.pptx
+++ b/deck/NIGHTWATCH-DataNova2026.pptx
@@ -120,25 +120,25 @@
   <p:extLst>
     <p:ext uri="{521415D9-36F7-43E2-AB2F-B90AF26B5E84}">
       <p14:sectionLst xmlns:p14="http://schemas.microsoft.com/office/powerpoint/2010/main">
-        <p14:section name="Opening" id="{4d60c91c-aee4-81f3-7f06-d311ab741684}">
+        <p14:section name="Opening" id="{01dcf5b2-fa29-67f1-4214-1ce0074e55b1}">
           <p14:sldIdLst>
             <p14:sldId id="256"/>
           </p14:sldIdLst>
         </p14:section>
-        <p14:section name="Problem" id="{6b38cab6-78f3-2ac4-d0ca-35b9009bd714}">
+        <p14:section name="Problem" id="{9d5b7cab-a069-c374-bb07-38e5b8a19008}">
           <p14:sldIdLst>
             <p14:sldId id="257"/>
             <p14:sldId id="258"/>
           </p14:sldIdLst>
         </p14:section>
-        <p14:section name="Solution" id="{7e72a43e-52e8-3632-ff00-32db246302ec}">
+        <p14:section name="Solution" id="{5da8c7b0-f2bd-bb50-90c8-50b4d06def33}">
           <p14:sldIdLst>
             <p14:sldId id="259"/>
             <p14:sldId id="260"/>
             <p14:sldId id="261"/>
           </p14:sldIdLst>
         </p14:section>
-        <p14:section name="Evidence" id="{df6078f1-a705-18d8-dd0e-f828b0abed7c}">
+        <p14:section name="Evidence" id="{a3a4efd8-3139-c271-b458-92577584022f}">
           <p14:sldIdLst>
             <p14:sldId id="262"/>
             <p14:sldId id="263"/>
@@ -146,14 +146,14 @@
             <p14:sldId id="265"/>
           </p14:sldIdLst>
         </p14:section>
-        <p14:section name="Impact" id="{d1dd6630-6b7a-f243-0250-5c1b2a45d3d6}">
+        <p14:section name="Impact" id="{506c1f8f-4886-ef0e-0f71-1bca4b57bc6a}">
           <p14:sldIdLst>
             <p14:sldId id="266"/>
             <p14:sldId id="267"/>
             <p14:sldId id="268"/>
           </p14:sldIdLst>
         </p14:section>
-        <p14:section name="Close" id="{ae95430d-e911-b159-6ff2-15b4eb344403}">
+        <p14:section name="Close" id="{aee43b00-7002-bb21-4b95-be3af58f064c}">
           <p14:sldIdLst>
             <p14:sldId id="269"/>
           </p14:sldIdLst>
@@ -6110,7 +6110,7 @@
         <p:spPr>
           <a:xfrm>
             <a:off x="548640" y="4297680"/>
-            <a:ext cx="2697480" cy="365760"/>
+            <a:ext cx="2514600" cy="365760"/>
           </a:xfrm>
           <a:prstGeom prst="rect">
             <a:avLst/>
@@ -6146,7 +6146,7 @@
         <p:spPr>
           <a:xfrm>
             <a:off x="548640" y="4709160"/>
-            <a:ext cx="2697480" cy="1005840"/>
+            <a:ext cx="2514600" cy="1005840"/>
           </a:xfrm>
           <a:prstGeom prst="rect">
             <a:avLst/>
@@ -6167,7 +6167,21 @@
                   <a:schemeClr val="bg2"/>
                 </a:solidFill>
               </a:rPr>
-              <a:t>Live demo link in the Devpost submission. Sign in with the judge demo account button.</a:t>
+              <a:t>nightwatch-olive.vercel.app</a:t>
+            </a:r>
+            <a:endParaRPr lang="en-US" sz="1400" dirty="0"/>
+          </a:p>
+          <a:p>
+            <a:pPr indent="0" marL="0">
+              <a:buNone/>
+            </a:pPr>
+            <a:r>
+              <a:rPr lang="en-US" sz="1400" dirty="0">
+                <a:solidFill>
+                  <a:schemeClr val="bg2"/>
+                </a:solidFill>
+              </a:rPr>
+              <a:t>Press “Use the judge demo account” to sign in.</a:t>
             </a:r>
             <a:endParaRPr lang="en-US" sz="1400" dirty="0"/>
           </a:p>
@@ -6181,8 +6195,8 @@
         </p:nvSpPr>
         <p:spPr>
           <a:xfrm>
-            <a:off x="3474720" y="4297680"/>
-            <a:ext cx="2697480" cy="365760"/>
+            <a:off x="3246120" y="4297680"/>
+            <a:ext cx="3246120" cy="365760"/>
           </a:xfrm>
           <a:prstGeom prst="rect">
             <a:avLst/>
@@ -6203,7 +6217,7 @@
                   <a:schemeClr val="bg1"/>
                 </a:solidFill>
               </a:rPr>
-              <a:t>Method</a:t>
+              <a:t>Code</a:t>
             </a:r>
             <a:endParaRPr lang="en-US" sz="1600" dirty="0"/>
           </a:p>
@@ -6217,8 +6231,8 @@
         </p:nvSpPr>
         <p:spPr>
           <a:xfrm>
-            <a:off x="3474720" y="4709160"/>
-            <a:ext cx="2697480" cy="1005840"/>
+            <a:off x="3246120" y="4709160"/>
+            <a:ext cx="3246120" cy="1005840"/>
           </a:xfrm>
           <a:prstGeom prst="rect">
             <a:avLst/>
@@ -6239,15 +6253,29 @@
                   <a:schemeClr val="bg2"/>
                 </a:solidFill>
               </a:rPr>
-              <a:t>Every number in this deck is regenerated from the code in the repository.</a:t>
+              <a:t>github.com/yuan05-afk/nightwatch</a:t>
             </a:r>
             <a:endParaRPr lang="en-US" sz="1400" dirty="0"/>
           </a:p>
-        </p:txBody>
-      </p:sp>
-      <p:sp>
-        <p:nvSpPr>
-          <p:cNvPr id="8" name="Nightwatch console start screen frame"/>
+          <a:p>
+            <a:pPr indent="0" marL="0">
+              <a:buNone/>
+            </a:pPr>
+            <a:r>
+              <a:rPr lang="en-US" sz="1400" dirty="0">
+                <a:solidFill>
+                  <a:schemeClr val="bg2"/>
+                </a:solidFill>
+              </a:rPr>
+              <a:t>Every number in this deck is regenerated from it.</a:t>
+            </a:r>
+            <a:endParaRPr lang="en-US" sz="1400" dirty="0"/>
+          </a:p>
+        </p:txBody>
+      </p:sp>
+      <p:sp>
+        <p:nvSpPr>
+          <p:cNvPr id="8" name="Nightwatch security console frame"/>
           <p:cNvSpPr/>
           <p:nvPr/>
         </p:nvSpPr>
@@ -6272,7 +6300,7 @@
       </p:sp>
       <p:pic>
         <p:nvPicPr>
-          <p:cNvPr id="9" name="Nightwatch console start screen" descr="Nightwatch console start screen">    </p:cNvPr>
+          <p:cNvPr id="9" name="Nightwatch security console" descr="Nightwatch security console">    </p:cNvPr>
           <p:cNvPicPr>
             <a:picLocks noChangeAspect="1"/>
           </p:cNvPicPr>
@@ -9151,7 +9179,7 @@
                   <a:schemeClr val="bg2"/>
                 </a:solidFill>
               </a:rPr>
-              <a:t>What happened in plain words, MITRE ATT&amp;CK T1071, the model's evidence with an innocent explanation beside each signal, and the first three response steps.</a:t>
+              <a:t>What happened in plain words, MITRE ATT&amp;CK T1071, the model's evidence with an innocent explanation beside each signal, and the first response steps.</a:t>
             </a:r>
             <a:endParaRPr lang="en-US" sz="1400" dirty="0"/>
           </a:p>

</xml_diff>